<commit_message>
update diapo regul avec RGPD
</commit_message>
<xml_diff>
--- a/ressources/j4/1_matin/bloc-2-gouvernance-ia.pptx
+++ b/ressources/j4/1_matin/bloc-2-gouvernance-ia.pptx
@@ -55,14 +55,18 @@
       <p:font typeface="Open Sans" panose="020B0606030504020204" pitchFamily="34" charset="0"/>
       <p:regular r:id="rId42"/>
       <p:bold r:id="rId43"/>
+      <p:italic r:id="rId44"/>
+      <p:boldItalic r:id="rId45"/>
     </p:embeddedFont>
     <p:embeddedFont>
-      <p:font typeface="Open Sans Bold" panose="020B0806030504020204" charset="0"/>
-      <p:regular r:id="rId44"/>
+      <p:font typeface="Open Sans Bold" panose="020B0806030504020204"/>
+      <p:regular r:id="rId46"/>
+      <p:bold r:id="rId47"/>
     </p:embeddedFont>
     <p:embeddedFont>
-      <p:font typeface="Open Sans Italics" panose="020B0604020202020204" charset="0"/>
-      <p:regular r:id="rId45"/>
+      <p:font typeface="Open Sans Italics" panose="020B0606030504020204" pitchFamily="34" charset="0"/>
+      <p:regular r:id="rId48"/>
+      <p:italic r:id="rId49"/>
     </p:embeddedFont>
   </p:embeddedFontLst>
   <p:defaultTextStyle>
@@ -261,7 +265,7 @@
           <a:p>
             <a:fld id="{B7268E1E-0E44-426D-905E-8AD9B19D2182}" type="datetimeFigureOut">
               <a:rPr lang="cs-CZ" smtClean="0"/>
-              <a:t>12.06.2026</a:t>
+              <a:t>15.06.2026</a:t>
             </a:fld>
             <a:endParaRPr lang="cs-CZ"/>
           </a:p>
@@ -626,6 +630,236 @@
 </p:notes>
 </file>
 
+<file path=ppt/notesSlides/notesSlide10.xml><?xml version="1.0" encoding="utf-8"?>
+<p:notes xmlns:a="http://schemas.openxmlformats.org/drawingml/2006/main" xmlns:r="http://schemas.openxmlformats.org/officeDocument/2006/relationships" xmlns:p="http://schemas.openxmlformats.org/presentationml/2006/main">
+  <p:cSld>
+    <p:spTree>
+      <p:nvGrpSpPr>
+        <p:cNvPr id="1" name=""/>
+        <p:cNvGrpSpPr/>
+        <p:nvPr/>
+      </p:nvGrpSpPr>
+      <p:grpSpPr>
+        <a:xfrm>
+          <a:off x="0" y="0"/>
+          <a:ext cx="0" cy="0"/>
+          <a:chOff x="0" y="0"/>
+          <a:chExt cx="0" cy="0"/>
+        </a:xfrm>
+      </p:grpSpPr>
+      <p:sp>
+        <p:nvSpPr>
+          <p:cNvPr id="2" name="Header Placeholder 1"/>
+          <p:cNvSpPr>
+            <a:spLocks noGrp="1"/>
+          </p:cNvSpPr>
+          <p:nvPr>
+            <p:ph type="hdr" sz="quarter"/>
+          </p:nvPr>
+        </p:nvSpPr>
+        <p:spPr>
+          <a:xfrm>
+            <a:off x="0" y="0"/>
+            <a:ext cx="3962400" cy="342900"/>
+          </a:xfrm>
+          <a:prstGeom prst="rect">
+            <a:avLst/>
+          </a:prstGeom>
+        </p:spPr>
+        <p:txBody>
+          <a:bodyPr vert="horz" lIns="91440" tIns="45720" rIns="91440" bIns="45720" rtlCol="0"/>
+          <a:lstStyle>
+            <a:lvl1pPr algn="l">
+              <a:defRPr sz="1200"/>
+            </a:lvl1pPr>
+          </a:lstStyle>
+          <a:p>
+            <a:endParaRPr/>
+          </a:p>
+        </p:txBody>
+      </p:sp>
+      <p:sp>
+        <p:nvSpPr>
+          <p:cNvPr id="3" name="Date Placeholder 2"/>
+          <p:cNvSpPr>
+            <a:spLocks noGrp="1"/>
+          </p:cNvSpPr>
+          <p:nvPr>
+            <p:ph type="dt" idx="1"/>
+          </p:nvPr>
+        </p:nvSpPr>
+        <p:spPr>
+          <a:xfrm>
+            <a:off x="5180013" y="0"/>
+            <a:ext cx="3962400" cy="342900"/>
+          </a:xfrm>
+          <a:prstGeom prst="rect">
+            <a:avLst/>
+          </a:prstGeom>
+        </p:spPr>
+        <p:txBody>
+          <a:bodyPr vert="horz" lIns="91440" tIns="45720" rIns="91440" bIns="45720" rtlCol="0"/>
+          <a:lstStyle>
+            <a:lvl1pPr algn="r">
+              <a:defRPr sz="1200"/>
+            </a:lvl1pPr>
+          </a:lstStyle>
+          <a:p>
+            <a:r>
+              <a:rPr lang="cs-CZ"/>
+              <a:t>1.7.2013</a:t>
+            </a:r>
+          </a:p>
+        </p:txBody>
+      </p:sp>
+      <p:sp>
+        <p:nvSpPr>
+          <p:cNvPr id="4" name="Slide Image Placeholder 3"/>
+          <p:cNvSpPr>
+            <a:spLocks noGrp="1" noRot="1" noChangeAspect="1"/>
+          </p:cNvSpPr>
+          <p:nvPr>
+            <p:ph type="sldImg" idx="2"/>
+          </p:nvPr>
+        </p:nvSpPr>
+        <p:spPr>
+          <a:xfrm>
+            <a:off x="2290763" y="512763"/>
+            <a:ext cx="4562475" cy="2566987"/>
+          </a:xfrm>
+          <a:prstGeom prst="rect">
+            <a:avLst/>
+          </a:prstGeom>
+          <a:noFill/>
+          <a:ln w="12700">
+            <a:solidFill>
+              <a:prstClr val="black"/>
+            </a:solidFill>
+          </a:ln>
+        </p:spPr>
+        <p:txBody>
+          <a:bodyPr vert="horz" lIns="91440" tIns="45720" rIns="91440" bIns="45720" rtlCol="0" anchor="ctr"/>
+          <a:lstStyle/>
+          <a:p>
+            <a:endParaRPr/>
+          </a:p>
+        </p:txBody>
+      </p:sp>
+      <p:sp>
+        <p:nvSpPr>
+          <p:cNvPr id="5" name="Notes Placeholder 4"/>
+          <p:cNvSpPr>
+            <a:spLocks noGrp="1"/>
+          </p:cNvSpPr>
+          <p:nvPr>
+            <p:ph type="body" sz="quarter" idx="3"/>
+          </p:nvPr>
+        </p:nvSpPr>
+        <p:spPr>
+          <a:xfrm>
+            <a:off x="914400" y="3251200"/>
+            <a:ext cx="7315200" cy="3081338"/>
+          </a:xfrm>
+          <a:prstGeom prst="rect">
+            <a:avLst/>
+          </a:prstGeom>
+        </p:spPr>
+        <p:txBody>
+          <a:bodyPr vert="horz" lIns="91440" tIns="45720" rIns="91440" bIns="45720" rtlCol="0"/>
+          <a:lstStyle/>
+          <a:p>
+            <a:r>
+              <a:rPr lang="en-US"/>
+              <a:t>Exemple: Sélectionner des candidatures sur base de CV</a:t>
+            </a:r>
+          </a:p>
+          <a:p>
+            <a:r>
+              <a:rPr lang="en-US"/>
+              <a:t>Provider : l’entreprise qui développe l’outil et le vend : elle doit s’assurer que le système est correctement testé, documenté et conforme à l’AI Act.</a:t>
+            </a:r>
+          </a:p>
+          <a:p>
+            <a:r>
+              <a:rPr lang="en-US"/>
+              <a:t>Deployer : l’organisation qui utilise cet outil pour ses recrutements : elle doit l’utiliser correctement, former les personnes qui s’en servent, vérifier les résultats, garder une supervision humaine et informer les candidat·es qu'un outil est utilisé</a:t>
+            </a:r>
+          </a:p>
+        </p:txBody>
+      </p:sp>
+      <p:sp>
+        <p:nvSpPr>
+          <p:cNvPr id="6" name="Footer Placeholder 5"/>
+          <p:cNvSpPr>
+            <a:spLocks noGrp="1"/>
+          </p:cNvSpPr>
+          <p:nvPr>
+            <p:ph type="ftr" sz="quarter" idx="4"/>
+          </p:nvPr>
+        </p:nvSpPr>
+        <p:spPr>
+          <a:xfrm>
+            <a:off x="0" y="6502400"/>
+            <a:ext cx="3962400" cy="341313"/>
+          </a:xfrm>
+          <a:prstGeom prst="rect">
+            <a:avLst/>
+          </a:prstGeom>
+        </p:spPr>
+        <p:txBody>
+          <a:bodyPr vert="horz" lIns="91440" tIns="45720" rIns="91440" bIns="45720" rtlCol="0" anchor="b"/>
+          <a:lstStyle>
+            <a:lvl1pPr algn="l">
+              <a:defRPr sz="1200"/>
+            </a:lvl1pPr>
+          </a:lstStyle>
+          <a:p>
+            <a:endParaRPr/>
+          </a:p>
+        </p:txBody>
+      </p:sp>
+      <p:sp>
+        <p:nvSpPr>
+          <p:cNvPr id="7" name="Slide Number Placeholder 6"/>
+          <p:cNvSpPr>
+            <a:spLocks noGrp="1"/>
+          </p:cNvSpPr>
+          <p:nvPr>
+            <p:ph type="sldNum" sz="quarter" idx="5"/>
+          </p:nvPr>
+        </p:nvSpPr>
+        <p:spPr>
+          <a:xfrm>
+            <a:off x="5180013" y="6502400"/>
+            <a:ext cx="3962400" cy="341313"/>
+          </a:xfrm>
+          <a:prstGeom prst="rect">
+            <a:avLst/>
+          </a:prstGeom>
+        </p:spPr>
+        <p:txBody>
+          <a:bodyPr vert="horz" lIns="91440" tIns="45720" rIns="91440" bIns="45720" rtlCol="0" anchor="b"/>
+          <a:lstStyle>
+            <a:lvl1pPr algn="r">
+              <a:defRPr sz="1200"/>
+            </a:lvl1pPr>
+          </a:lstStyle>
+          <a:p>
+            <a:r>
+              <a:rPr lang="cs-CZ"/>
+              <a:t>‹#›</a:t>
+            </a:r>
+          </a:p>
+        </p:txBody>
+      </p:sp>
+    </p:spTree>
+  </p:cSld>
+  <p:clrMapOvr>
+    <a:masterClrMapping/>
+  </p:clrMapOvr>
+</p:notes>
+</file>
+
 <file path=ppt/notesSlides/notesSlide2.xml><?xml version="1.0" encoding="utf-8"?>
 <p:notes xmlns:a="http://schemas.openxmlformats.org/drawingml/2006/main" xmlns:r="http://schemas.openxmlformats.org/officeDocument/2006/relationships" xmlns:p="http://schemas.openxmlformats.org/presentationml/2006/main">
   <p:cSld>
@@ -675,39 +909,7 @@
           <a:bodyPr/>
           <a:lstStyle/>
           <a:p>
-            <a:r>
-              <a:rPr lang="fr-FR" dirty="0"/>
-              <a:t>Article Nature (début mai 2026)</a:t>
-            </a:r>
-          </a:p>
-          <a:p>
-            <a:r>
-              <a:rPr lang="fr-FR" dirty="0"/>
-              <a:t>Simulation d’utilisateurs </a:t>
-            </a:r>
-            <a:r>
-              <a:rPr lang="fr-FR" dirty="0" err="1"/>
-              <a:t>Tiktok</a:t>
-            </a:r>
-            <a:r>
-              <a:rPr lang="fr-FR" dirty="0"/>
-              <a:t> lors des élections américaines de 2024: républicains (droite, Donald Trump) et démocrates (gauche, Kamala Harris). </a:t>
-            </a:r>
-          </a:p>
-          <a:p>
-            <a:r>
-              <a:rPr lang="fr-FR" dirty="0"/>
-              <a:t>Profils républicains recevaient davantage de contenu aligné, tandis que les comptes démocrates étaient davantage exposés à du contenu opposé, souvent </a:t>
-            </a:r>
-            <a:r>
-              <a:rPr lang="fr-FR" dirty="0" err="1"/>
-              <a:t>anti-démocrate</a:t>
-            </a:r>
-            <a:r>
-              <a:rPr lang="fr-FR" dirty="0"/>
-              <a:t>.</a:t>
-            </a:r>
-            <a:endParaRPr lang="fr-BE" dirty="0"/>
+            <a:endParaRPr lang="fr-FR" dirty="0"/>
           </a:p>
         </p:txBody>
       </p:sp>
@@ -728,7 +930,7 @@
           <a:p>
             <a:fld id="{871B2431-D351-4C6E-A3CF-9DFAC0E3E050}" type="slidenum">
               <a:rPr lang="cs-CZ" smtClean="0"/>
-              <a:t>10</a:t>
+              <a:t>4</a:t>
             </a:fld>
             <a:endParaRPr lang="cs-CZ"/>
           </a:p>
@@ -737,7 +939,7 @@
     </p:spTree>
     <p:extLst>
       <p:ext uri="{BB962C8B-B14F-4D97-AF65-F5344CB8AC3E}">
-        <p14:creationId xmlns:p14="http://schemas.microsoft.com/office/powerpoint/2010/main" val="58002898"/>
+        <p14:creationId xmlns:p14="http://schemas.microsoft.com/office/powerpoint/2010/main" val="3032020292"/>
       </p:ext>
     </p:extLst>
   </p:cSld>
@@ -766,167 +968,43 @@
       </p:grpSpPr>
       <p:sp>
         <p:nvSpPr>
-          <p:cNvPr id="2" name="Header Placeholder 1"/>
+          <p:cNvPr id="2" name="Espace réservé de l'image des diapositives 1"/>
+          <p:cNvSpPr>
+            <a:spLocks noGrp="1" noRot="1" noChangeAspect="1"/>
+          </p:cNvSpPr>
+          <p:nvPr>
+            <p:ph type="sldImg"/>
+          </p:nvPr>
+        </p:nvSpPr>
+        <p:spPr>
+          <a:xfrm>
+            <a:off x="2290763" y="512763"/>
+            <a:ext cx="4562475" cy="2566987"/>
+          </a:xfrm>
+        </p:spPr>
+      </p:sp>
+      <p:sp>
+        <p:nvSpPr>
+          <p:cNvPr id="3" name="Espace réservé des notes 2"/>
           <p:cNvSpPr>
             <a:spLocks noGrp="1"/>
           </p:cNvSpPr>
           <p:nvPr>
-            <p:ph type="hdr" sz="quarter"/>
+            <p:ph type="body" idx="1"/>
           </p:nvPr>
         </p:nvSpPr>
-        <p:spPr>
-          <a:xfrm>
-            <a:off x="0" y="0"/>
-            <a:ext cx="3962400" cy="342900"/>
-          </a:xfrm>
-          <a:prstGeom prst="rect">
-            <a:avLst/>
-          </a:prstGeom>
-        </p:spPr>
-        <p:txBody>
-          <a:bodyPr vert="horz" lIns="91440" tIns="45720" rIns="91440" bIns="45720" rtlCol="0"/>
-          <a:lstStyle>
-            <a:lvl1pPr algn="l">
-              <a:defRPr sz="1200"/>
-            </a:lvl1pPr>
-          </a:lstStyle>
-          <a:p>
-            <a:endParaRPr/>
-          </a:p>
-        </p:txBody>
-      </p:sp>
-      <p:sp>
-        <p:nvSpPr>
-          <p:cNvPr id="3" name="Date Placeholder 2"/>
-          <p:cNvSpPr>
-            <a:spLocks noGrp="1"/>
-          </p:cNvSpPr>
-          <p:nvPr>
-            <p:ph type="dt" idx="1"/>
-          </p:nvPr>
-        </p:nvSpPr>
-        <p:spPr>
-          <a:xfrm>
-            <a:off x="5180013" y="0"/>
-            <a:ext cx="3962400" cy="342900"/>
-          </a:xfrm>
-          <a:prstGeom prst="rect">
-            <a:avLst/>
-          </a:prstGeom>
-        </p:spPr>
-        <p:txBody>
-          <a:bodyPr vert="horz" lIns="91440" tIns="45720" rIns="91440" bIns="45720" rtlCol="0"/>
-          <a:lstStyle>
-            <a:lvl1pPr algn="r">
-              <a:defRPr sz="1200"/>
-            </a:lvl1pPr>
-          </a:lstStyle>
-          <a:p>
-            <a:r>
-              <a:rPr lang="cs-CZ"/>
-              <a:t>1.7.2013</a:t>
-            </a:r>
-          </a:p>
-        </p:txBody>
-      </p:sp>
-      <p:sp>
-        <p:nvSpPr>
-          <p:cNvPr id="4" name="Slide Image Placeholder 3"/>
-          <p:cNvSpPr>
-            <a:spLocks noGrp="1" noRot="1" noChangeAspect="1"/>
-          </p:cNvSpPr>
-          <p:nvPr>
-            <p:ph type="sldImg" idx="2"/>
-          </p:nvPr>
-        </p:nvSpPr>
-        <p:spPr>
-          <a:xfrm>
-            <a:off x="2290763" y="512763"/>
-            <a:ext cx="4562475" cy="2566987"/>
-          </a:xfrm>
-          <a:prstGeom prst="rect">
-            <a:avLst/>
-          </a:prstGeom>
-          <a:noFill/>
-          <a:ln w="12700">
-            <a:solidFill>
-              <a:prstClr val="black"/>
-            </a:solidFill>
-          </a:ln>
-        </p:spPr>
-        <p:txBody>
-          <a:bodyPr vert="horz" lIns="91440" tIns="45720" rIns="91440" bIns="45720" rtlCol="0" anchor="ctr"/>
+        <p:spPr/>
+        <p:txBody>
+          <a:bodyPr/>
           <a:lstStyle/>
           <a:p>
-            <a:endParaRPr/>
-          </a:p>
-        </p:txBody>
-      </p:sp>
-      <p:sp>
-        <p:nvSpPr>
-          <p:cNvPr id="5" name="Notes Placeholder 4"/>
-          <p:cNvSpPr>
-            <a:spLocks noGrp="1"/>
-          </p:cNvSpPr>
-          <p:nvPr>
-            <p:ph type="body" sz="quarter" idx="3"/>
-          </p:nvPr>
-        </p:nvSpPr>
-        <p:spPr>
-          <a:xfrm>
-            <a:off x="914400" y="3251200"/>
-            <a:ext cx="7315200" cy="3081338"/>
-          </a:xfrm>
-          <a:prstGeom prst="rect">
-            <a:avLst/>
-          </a:prstGeom>
-        </p:spPr>
-        <p:txBody>
-          <a:bodyPr vert="horz" lIns="91440" tIns="45720" rIns="91440" bIns="45720" rtlCol="0"/>
-          <a:lstStyle/>
-          <a:p>
-            <a:r>
-              <a:rPr lang="fr-FR" dirty="0"/>
-              <a:t>Le système n’a pas identifié correctement le camion, notamment parce que la remorque blanche se détachait mal sur le ciel lumineux. </a:t>
-            </a:r>
-            <a:endParaRPr lang="en-US" dirty="0"/>
-          </a:p>
-        </p:txBody>
-      </p:sp>
-      <p:sp>
-        <p:nvSpPr>
-          <p:cNvPr id="6" name="Footer Placeholder 5"/>
-          <p:cNvSpPr>
-            <a:spLocks noGrp="1"/>
-          </p:cNvSpPr>
-          <p:nvPr>
-            <p:ph type="ftr" sz="quarter" idx="4"/>
-          </p:nvPr>
-        </p:nvSpPr>
-        <p:spPr>
-          <a:xfrm>
-            <a:off x="0" y="6502400"/>
-            <a:ext cx="3962400" cy="341313"/>
-          </a:xfrm>
-          <a:prstGeom prst="rect">
-            <a:avLst/>
-          </a:prstGeom>
-        </p:spPr>
-        <p:txBody>
-          <a:bodyPr vert="horz" lIns="91440" tIns="45720" rIns="91440" bIns="45720" rtlCol="0" anchor="b"/>
-          <a:lstStyle>
-            <a:lvl1pPr algn="l">
-              <a:defRPr sz="1200"/>
-            </a:lvl1pPr>
-          </a:lstStyle>
-          <a:p>
-            <a:endParaRPr/>
-          </a:p>
-        </p:txBody>
-      </p:sp>
-      <p:sp>
-        <p:nvSpPr>
-          <p:cNvPr id="7" name="Slide Number Placeholder 6"/>
+            <a:endParaRPr lang="fr-FR" dirty="0"/>
+          </a:p>
+        </p:txBody>
+      </p:sp>
+      <p:sp>
+        <p:nvSpPr>
+          <p:cNvPr id="4" name="Espace réservé du numéro de diapositive 3"/>
           <p:cNvSpPr>
             <a:spLocks noGrp="1"/>
           </p:cNvSpPr>
@@ -934,31 +1012,25 @@
             <p:ph type="sldNum" sz="quarter" idx="5"/>
           </p:nvPr>
         </p:nvSpPr>
-        <p:spPr>
-          <a:xfrm>
-            <a:off x="5180013" y="6502400"/>
-            <a:ext cx="3962400" cy="341313"/>
-          </a:xfrm>
-          <a:prstGeom prst="rect">
-            <a:avLst/>
-          </a:prstGeom>
-        </p:spPr>
-        <p:txBody>
-          <a:bodyPr vert="horz" lIns="91440" tIns="45720" rIns="91440" bIns="45720" rtlCol="0" anchor="b"/>
-          <a:lstStyle>
-            <a:lvl1pPr algn="r">
-              <a:defRPr sz="1200"/>
-            </a:lvl1pPr>
-          </a:lstStyle>
-          <a:p>
-            <a:r>
-              <a:rPr lang="cs-CZ"/>
-              <a:t>‹#›</a:t>
-            </a:r>
+        <p:spPr/>
+        <p:txBody>
+          <a:bodyPr/>
+          <a:lstStyle/>
+          <a:p>
+            <a:fld id="{871B2431-D351-4C6E-A3CF-9DFAC0E3E050}" type="slidenum">
+              <a:rPr lang="cs-CZ" smtClean="0"/>
+              <a:t>5</a:t>
+            </a:fld>
+            <a:endParaRPr lang="cs-CZ"/>
           </a:p>
         </p:txBody>
       </p:sp>
     </p:spTree>
+    <p:extLst>
+      <p:ext uri="{BB962C8B-B14F-4D97-AF65-F5344CB8AC3E}">
+        <p14:creationId xmlns:p14="http://schemas.microsoft.com/office/powerpoint/2010/main" val="2031928020"/>
+      </p:ext>
+    </p:extLst>
   </p:cSld>
   <p:clrMapOvr>
     <a:masterClrMapping/>
@@ -985,166 +1057,75 @@
       </p:grpSpPr>
       <p:sp>
         <p:nvSpPr>
-          <p:cNvPr id="2" name="Header Placeholder 1"/>
+          <p:cNvPr id="2" name="Espace réservé de l'image des diapositives 1"/>
+          <p:cNvSpPr>
+            <a:spLocks noGrp="1" noRot="1" noChangeAspect="1"/>
+          </p:cNvSpPr>
+          <p:nvPr>
+            <p:ph type="sldImg"/>
+          </p:nvPr>
+        </p:nvSpPr>
+        <p:spPr>
+          <a:xfrm>
+            <a:off x="2290763" y="512763"/>
+            <a:ext cx="4562475" cy="2566987"/>
+          </a:xfrm>
+        </p:spPr>
+      </p:sp>
+      <p:sp>
+        <p:nvSpPr>
+          <p:cNvPr id="3" name="Espace réservé des notes 2"/>
           <p:cNvSpPr>
             <a:spLocks noGrp="1"/>
           </p:cNvSpPr>
           <p:nvPr>
-            <p:ph type="hdr" sz="quarter"/>
+            <p:ph type="body" idx="1"/>
           </p:nvPr>
         </p:nvSpPr>
-        <p:spPr>
-          <a:xfrm>
-            <a:off x="0" y="0"/>
-            <a:ext cx="3962400" cy="342900"/>
-          </a:xfrm>
-          <a:prstGeom prst="rect">
-            <a:avLst/>
-          </a:prstGeom>
-        </p:spPr>
-        <p:txBody>
-          <a:bodyPr vert="horz" lIns="91440" tIns="45720" rIns="91440" bIns="45720" rtlCol="0"/>
-          <a:lstStyle>
-            <a:lvl1pPr algn="l">
-              <a:defRPr sz="1200"/>
-            </a:lvl1pPr>
-          </a:lstStyle>
-          <a:p>
-            <a:endParaRPr/>
-          </a:p>
-        </p:txBody>
-      </p:sp>
-      <p:sp>
-        <p:nvSpPr>
-          <p:cNvPr id="3" name="Date Placeholder 2"/>
-          <p:cNvSpPr>
-            <a:spLocks noGrp="1"/>
-          </p:cNvSpPr>
-          <p:nvPr>
-            <p:ph type="dt" idx="1"/>
-          </p:nvPr>
-        </p:nvSpPr>
-        <p:spPr>
-          <a:xfrm>
-            <a:off x="5180013" y="0"/>
-            <a:ext cx="3962400" cy="342900"/>
-          </a:xfrm>
-          <a:prstGeom prst="rect">
-            <a:avLst/>
-          </a:prstGeom>
-        </p:spPr>
-        <p:txBody>
-          <a:bodyPr vert="horz" lIns="91440" tIns="45720" rIns="91440" bIns="45720" rtlCol="0"/>
-          <a:lstStyle>
-            <a:lvl1pPr algn="r">
-              <a:defRPr sz="1200"/>
-            </a:lvl1pPr>
-          </a:lstStyle>
-          <a:p>
-            <a:r>
-              <a:rPr lang="cs-CZ"/>
-              <a:t>1.7.2013</a:t>
-            </a:r>
-          </a:p>
-        </p:txBody>
-      </p:sp>
-      <p:sp>
-        <p:nvSpPr>
-          <p:cNvPr id="4" name="Slide Image Placeholder 3"/>
-          <p:cNvSpPr>
-            <a:spLocks noGrp="1" noRot="1" noChangeAspect="1"/>
-          </p:cNvSpPr>
-          <p:nvPr>
-            <p:ph type="sldImg" idx="2"/>
-          </p:nvPr>
-        </p:nvSpPr>
-        <p:spPr>
-          <a:xfrm>
-            <a:off x="2857500" y="512763"/>
-            <a:ext cx="3429000" cy="2566987"/>
-          </a:xfrm>
-          <a:prstGeom prst="rect">
-            <a:avLst/>
-          </a:prstGeom>
-          <a:noFill/>
-          <a:ln w="12700">
-            <a:solidFill>
-              <a:prstClr val="black"/>
-            </a:solidFill>
-          </a:ln>
-        </p:spPr>
-        <p:txBody>
-          <a:bodyPr vert="horz" lIns="91440" tIns="45720" rIns="91440" bIns="45720" rtlCol="0" anchor="ctr"/>
+        <p:spPr/>
+        <p:txBody>
+          <a:bodyPr/>
           <a:lstStyle/>
           <a:p>
-            <a:endParaRPr/>
-          </a:p>
-        </p:txBody>
-      </p:sp>
-      <p:sp>
-        <p:nvSpPr>
-          <p:cNvPr id="5" name="Notes Placeholder 4"/>
-          <p:cNvSpPr>
-            <a:spLocks noGrp="1"/>
-          </p:cNvSpPr>
-          <p:nvPr>
-            <p:ph type="body" sz="quarter" idx="3"/>
-          </p:nvPr>
-        </p:nvSpPr>
-        <p:spPr>
-          <a:xfrm>
-            <a:off x="914400" y="3251200"/>
-            <a:ext cx="7315200" cy="3081338"/>
-          </a:xfrm>
-          <a:prstGeom prst="rect">
-            <a:avLst/>
-          </a:prstGeom>
-        </p:spPr>
-        <p:txBody>
-          <a:bodyPr vert="horz" lIns="91440" tIns="45720" rIns="91440" bIns="45720" rtlCol="0"/>
-          <a:lstStyle/>
-          <a:p>
-            <a:r>
-              <a:rPr lang="en-US"/>
-              <a:t>Clearview AI est une entreprise de reconnaissance faciale qui a constitué une immense base de données en collectant des images de visages disponibles en ligne. Le problème est que ces images ont été transformées en données biométriques, donc en données très sensibles, sans base légale valable, sans information suffisante des personnes concernées, et sans respect effectif de leurs droits d’accès. En septembre 2024, l’autorité néerlandaise a annoncé une amende de 30,5 millions d’euros et une injonction de mise en conformité. Le cas illustre très bien le pilier Privacy and data governance, car il montre que les systèmes d’IA ne posent pas seulement des questions de performance, mais aussi de collecte, de légalité, de transparence et de gouvernance des données utilisées.</a:t>
-            </a:r>
-          </a:p>
-        </p:txBody>
-      </p:sp>
-      <p:sp>
-        <p:nvSpPr>
-          <p:cNvPr id="6" name="Footer Placeholder 5"/>
-          <p:cNvSpPr>
-            <a:spLocks noGrp="1"/>
-          </p:cNvSpPr>
-          <p:nvPr>
-            <p:ph type="ftr" sz="quarter" idx="4"/>
-          </p:nvPr>
-        </p:nvSpPr>
-        <p:spPr>
-          <a:xfrm>
-            <a:off x="0" y="6502400"/>
-            <a:ext cx="3962400" cy="341313"/>
-          </a:xfrm>
-          <a:prstGeom prst="rect">
-            <a:avLst/>
-          </a:prstGeom>
-        </p:spPr>
-        <p:txBody>
-          <a:bodyPr vert="horz" lIns="91440" tIns="45720" rIns="91440" bIns="45720" rtlCol="0" anchor="b"/>
-          <a:lstStyle>
-            <a:lvl1pPr algn="l">
-              <a:defRPr sz="1200"/>
-            </a:lvl1pPr>
-          </a:lstStyle>
-          <a:p>
-            <a:endParaRPr/>
-          </a:p>
-        </p:txBody>
-      </p:sp>
-      <p:sp>
-        <p:nvSpPr>
-          <p:cNvPr id="7" name="Slide Number Placeholder 6"/>
+            <a:r>
+              <a:rPr lang="fr-FR" dirty="0"/>
+              <a:t>Article Nature (début mai 2026)</a:t>
+            </a:r>
+          </a:p>
+          <a:p>
+            <a:r>
+              <a:rPr lang="fr-FR" dirty="0"/>
+              <a:t>Simulation d’utilisateurs </a:t>
+            </a:r>
+            <a:r>
+              <a:rPr lang="fr-FR" dirty="0" err="1"/>
+              <a:t>Tiktok</a:t>
+            </a:r>
+            <a:r>
+              <a:rPr lang="fr-FR" dirty="0"/>
+              <a:t> lors des élections américaines de 2024: républicains (droite, Donald Trump) et démocrates (gauche, Kamala Harris). </a:t>
+            </a:r>
+          </a:p>
+          <a:p>
+            <a:r>
+              <a:rPr lang="fr-FR" dirty="0"/>
+              <a:t>Profils républicains recevaient davantage de contenu aligné, tandis que les comptes démocrates étaient davantage exposés à du contenu opposé, souvent </a:t>
+            </a:r>
+            <a:r>
+              <a:rPr lang="fr-FR" dirty="0" err="1"/>
+              <a:t>anti-démocrate</a:t>
+            </a:r>
+            <a:r>
+              <a:rPr lang="fr-FR" dirty="0"/>
+              <a:t>.</a:t>
+            </a:r>
+            <a:endParaRPr lang="fr-BE" dirty="0"/>
+          </a:p>
+        </p:txBody>
+      </p:sp>
+      <p:sp>
+        <p:nvSpPr>
+          <p:cNvPr id="4" name="Espace réservé du numéro de diapositive 3"/>
           <p:cNvSpPr>
             <a:spLocks noGrp="1"/>
           </p:cNvSpPr>
@@ -1152,31 +1133,25 @@
             <p:ph type="sldNum" sz="quarter" idx="5"/>
           </p:nvPr>
         </p:nvSpPr>
-        <p:spPr>
-          <a:xfrm>
-            <a:off x="5180013" y="6502400"/>
-            <a:ext cx="3962400" cy="341313"/>
-          </a:xfrm>
-          <a:prstGeom prst="rect">
-            <a:avLst/>
-          </a:prstGeom>
-        </p:spPr>
-        <p:txBody>
-          <a:bodyPr vert="horz" lIns="91440" tIns="45720" rIns="91440" bIns="45720" rtlCol="0" anchor="b"/>
-          <a:lstStyle>
-            <a:lvl1pPr algn="r">
-              <a:defRPr sz="1200"/>
-            </a:lvl1pPr>
-          </a:lstStyle>
-          <a:p>
-            <a:r>
-              <a:rPr lang="cs-CZ"/>
-              <a:t>‹#›</a:t>
-            </a:r>
+        <p:spPr/>
+        <p:txBody>
+          <a:bodyPr/>
+          <a:lstStyle/>
+          <a:p>
+            <a:fld id="{871B2431-D351-4C6E-A3CF-9DFAC0E3E050}" type="slidenum">
+              <a:rPr lang="cs-CZ" smtClean="0"/>
+              <a:t>10</a:t>
+            </a:fld>
+            <a:endParaRPr lang="cs-CZ"/>
           </a:p>
         </p:txBody>
       </p:sp>
     </p:spTree>
+    <p:extLst>
+      <p:ext uri="{BB962C8B-B14F-4D97-AF65-F5344CB8AC3E}">
+        <p14:creationId xmlns:p14="http://schemas.microsoft.com/office/powerpoint/2010/main" val="58002898"/>
+      </p:ext>
+    </p:extLst>
   </p:cSld>
   <p:clrMapOvr>
     <a:masterClrMapping/>
@@ -1323,33 +1298,10 @@
           <a:lstStyle/>
           <a:p>
             <a:r>
-              <a:rPr lang="en-US"/>
-              <a:t>J'ai voulu faire un montage IA d'un ordinateur qui boit de l'eau pour illustrer la consommation d'eau mais du coup à l'encontre du pilier donc désolé pour ce montage approximatif mais plus écolo ;) </a:t>
-            </a:r>
-          </a:p>
-          <a:p>
-            <a:r>
-              <a:rPr lang="en-US"/>
-              <a:t>- Les data centers utilisent de l’eau pour refroidir les serveurs, notamment lorsque les systèmes de refroidissement par évaporation sont utilisés.</a:t>
-            </a:r>
-          </a:p>
-          <a:p>
-            <a:r>
-              <a:rPr lang="en-US"/>
-              <a:t>- Avec l’essor de l’IA générative, les besoins en calcul augmentent, donc la pression sur l’eau peut aussi augmenter.</a:t>
-            </a:r>
-          </a:p>
-          <a:p>
-            <a:r>
-              <a:rPr lang="en-US"/>
-              <a:t>- Un chiffre frappant : selon l’EESI, un grand data center peut consommer jusqu’à 5 millions de gallons d’eau par jour, soit environ 19 millions de litres par jour.</a:t>
-            </a:r>
-          </a:p>
-          <a:p>
-            <a:r>
-              <a:rPr lang="en-US"/>
-              <a:t>- Cela équivaut à la consommation d’eau d’une ville de 10 000 à 50 000 habitants.</a:t>
-            </a:r>
+              <a:rPr lang="fr-FR" dirty="0"/>
+              <a:t>Le système n’a pas identifié correctement le camion, notamment parce que la remorque blanche se détachait mal sur le ciel lumineux. </a:t>
+            </a:r>
+            <a:endParaRPr lang="en-US" dirty="0"/>
           </a:p>
         </p:txBody>
       </p:sp>
@@ -1566,7 +1518,7 @@
           <a:p>
             <a:r>
               <a:rPr lang="en-US"/>
-              <a:t>L’exemple est intéressant car il ne s’agit pas seulement de “robots tueurs” totalement autonomes, mais d’un cas plus réaliste : des systèmes d’IA qui aident à identifier des cibles militaires. Cela pose une question centrale d’accountability : si une IA recommande une cible et que des civils sont tués, qui est responsable ? Le concepteur du système, l’armée, le commandant, l’opérateur humain qui valide, ou l’État ? Human Rights Watch souligne en 2025 que l’usage de l’IA dans les décisions de ciblage militaire peut mettre en danger les principes du droit international humanitaire, notamment la distinction entre combattants et civils, et l’obligation de prendre toutes les précautions possibles pour limiter les dommages civils.</a:t>
+              <a:t>Clearview AI est une entreprise de reconnaissance faciale qui a constitué une immense base de données en collectant des images de visages disponibles en ligne. Le problème est que ces images ont été transformées en données biométriques, donc en données très sensibles, sans base légale valable, sans information suffisante des personnes concernées, et sans respect effectif de leurs droits d’accès. En septembre 2024, l’autorité néerlandaise a annoncé une amende de 30,5 millions d’euros et une injonction de mise en conformité. Le cas illustre très bien le pilier Privacy and data governance, car il montre que les systèmes d’IA ne posent pas seulement des questions de performance, mais aussi de collecte, de légalité, de transparence et de gouvernance des données utilisées.</a:t>
             </a:r>
           </a:p>
         </p:txBody>
@@ -1663,12 +1615,77 @@
       </p:grpSpPr>
       <p:sp>
         <p:nvSpPr>
-          <p:cNvPr id="2" name="Espace réservé de l'image des diapositives 1"/>
+          <p:cNvPr id="2" name="Header Placeholder 1"/>
+          <p:cNvSpPr>
+            <a:spLocks noGrp="1"/>
+          </p:cNvSpPr>
+          <p:nvPr>
+            <p:ph type="hdr" sz="quarter"/>
+          </p:nvPr>
+        </p:nvSpPr>
+        <p:spPr>
+          <a:xfrm>
+            <a:off x="0" y="0"/>
+            <a:ext cx="3962400" cy="342900"/>
+          </a:xfrm>
+          <a:prstGeom prst="rect">
+            <a:avLst/>
+          </a:prstGeom>
+        </p:spPr>
+        <p:txBody>
+          <a:bodyPr vert="horz" lIns="91440" tIns="45720" rIns="91440" bIns="45720" rtlCol="0"/>
+          <a:lstStyle>
+            <a:lvl1pPr algn="l">
+              <a:defRPr sz="1200"/>
+            </a:lvl1pPr>
+          </a:lstStyle>
+          <a:p>
+            <a:endParaRPr/>
+          </a:p>
+        </p:txBody>
+      </p:sp>
+      <p:sp>
+        <p:nvSpPr>
+          <p:cNvPr id="3" name="Date Placeholder 2"/>
+          <p:cNvSpPr>
+            <a:spLocks noGrp="1"/>
+          </p:cNvSpPr>
+          <p:nvPr>
+            <p:ph type="dt" idx="1"/>
+          </p:nvPr>
+        </p:nvSpPr>
+        <p:spPr>
+          <a:xfrm>
+            <a:off x="5180013" y="0"/>
+            <a:ext cx="3962400" cy="342900"/>
+          </a:xfrm>
+          <a:prstGeom prst="rect">
+            <a:avLst/>
+          </a:prstGeom>
+        </p:spPr>
+        <p:txBody>
+          <a:bodyPr vert="horz" lIns="91440" tIns="45720" rIns="91440" bIns="45720" rtlCol="0"/>
+          <a:lstStyle>
+            <a:lvl1pPr algn="r">
+              <a:defRPr sz="1200"/>
+            </a:lvl1pPr>
+          </a:lstStyle>
+          <a:p>
+            <a:r>
+              <a:rPr lang="cs-CZ"/>
+              <a:t>1.7.2013</a:t>
+            </a:r>
+          </a:p>
+        </p:txBody>
+      </p:sp>
+      <p:sp>
+        <p:nvSpPr>
+          <p:cNvPr id="4" name="Slide Image Placeholder 3"/>
           <p:cNvSpPr>
             <a:spLocks noGrp="1" noRot="1" noChangeAspect="1"/>
           </p:cNvSpPr>
           <p:nvPr>
-            <p:ph type="sldImg"/>
+            <p:ph type="sldImg" idx="2"/>
           </p:nvPr>
         </p:nvSpPr>
         <p:spPr>
@@ -1676,42 +1693,112 @@
             <a:off x="2290763" y="512763"/>
             <a:ext cx="4562475" cy="2566987"/>
           </a:xfrm>
+          <a:prstGeom prst="rect">
+            <a:avLst/>
+          </a:prstGeom>
+          <a:noFill/>
+          <a:ln w="12700">
+            <a:solidFill>
+              <a:prstClr val="black"/>
+            </a:solidFill>
+          </a:ln>
         </p:spPr>
-      </p:sp>
-      <p:sp>
-        <p:nvSpPr>
-          <p:cNvPr id="3" name="Espace réservé des notes 2"/>
+        <p:txBody>
+          <a:bodyPr vert="horz" lIns="91440" tIns="45720" rIns="91440" bIns="45720" rtlCol="0" anchor="ctr"/>
+          <a:lstStyle/>
+          <a:p>
+            <a:endParaRPr/>
+          </a:p>
+        </p:txBody>
+      </p:sp>
+      <p:sp>
+        <p:nvSpPr>
+          <p:cNvPr id="5" name="Notes Placeholder 4"/>
           <p:cNvSpPr>
             <a:spLocks noGrp="1"/>
           </p:cNvSpPr>
           <p:nvPr>
-            <p:ph type="body" idx="1"/>
+            <p:ph type="body" sz="quarter" idx="3"/>
           </p:nvPr>
         </p:nvSpPr>
-        <p:spPr/>
-        <p:txBody>
-          <a:bodyPr/>
+        <p:spPr>
+          <a:xfrm>
+            <a:off x="914400" y="3251200"/>
+            <a:ext cx="7315200" cy="3081338"/>
+          </a:xfrm>
+          <a:prstGeom prst="rect">
+            <a:avLst/>
+          </a:prstGeom>
+        </p:spPr>
+        <p:txBody>
+          <a:bodyPr vert="horz" lIns="91440" tIns="45720" rIns="91440" bIns="45720" rtlCol="0"/>
           <a:lstStyle/>
           <a:p>
             <a:r>
-              <a:rPr lang="fr-FR" dirty="0"/>
-              <a:t>Des principes éthiques aux obligations juridiques : l’AI </a:t>
-            </a:r>
-            <a:r>
-              <a:rPr lang="fr-FR" dirty="0" err="1"/>
-              <a:t>Act</a:t>
-            </a:r>
-            <a:r>
-              <a:rPr lang="fr-FR" dirty="0"/>
-              <a:t> traduit certains risques en règles concrètes. </a:t>
-            </a:r>
-            <a:endParaRPr lang="fr-BE" dirty="0"/>
-          </a:p>
-        </p:txBody>
-      </p:sp>
-      <p:sp>
-        <p:nvSpPr>
-          <p:cNvPr id="4" name="Espace réservé du numéro de diapositive 3"/>
+              <a:rPr lang="en-US"/>
+              <a:t>J'ai voulu faire un montage IA d'un ordinateur qui boit de l'eau pour illustrer la consommation d'eau mais du coup à l'encontre du pilier donc désolé pour ce montage approximatif mais plus écolo ;) </a:t>
+            </a:r>
+          </a:p>
+          <a:p>
+            <a:r>
+              <a:rPr lang="en-US"/>
+              <a:t>- Les data centers utilisent de l’eau pour refroidir les serveurs, notamment lorsque les systèmes de refroidissement par évaporation sont utilisés.</a:t>
+            </a:r>
+          </a:p>
+          <a:p>
+            <a:r>
+              <a:rPr lang="en-US"/>
+              <a:t>- Avec l’essor de l’IA générative, les besoins en calcul augmentent, donc la pression sur l’eau peut aussi augmenter.</a:t>
+            </a:r>
+          </a:p>
+          <a:p>
+            <a:r>
+              <a:rPr lang="en-US"/>
+              <a:t>- Un chiffre frappant : selon l’EESI, un grand data center peut consommer jusqu’à 5 millions de gallons d’eau par jour, soit environ 19 millions de litres par jour.</a:t>
+            </a:r>
+          </a:p>
+          <a:p>
+            <a:r>
+              <a:rPr lang="en-US"/>
+              <a:t>- Cela équivaut à la consommation d’eau d’une ville de 10 000 à 50 000 habitants.</a:t>
+            </a:r>
+          </a:p>
+        </p:txBody>
+      </p:sp>
+      <p:sp>
+        <p:nvSpPr>
+          <p:cNvPr id="6" name="Footer Placeholder 5"/>
+          <p:cNvSpPr>
+            <a:spLocks noGrp="1"/>
+          </p:cNvSpPr>
+          <p:nvPr>
+            <p:ph type="ftr" sz="quarter" idx="4"/>
+          </p:nvPr>
+        </p:nvSpPr>
+        <p:spPr>
+          <a:xfrm>
+            <a:off x="0" y="6502400"/>
+            <a:ext cx="3962400" cy="341313"/>
+          </a:xfrm>
+          <a:prstGeom prst="rect">
+            <a:avLst/>
+          </a:prstGeom>
+        </p:spPr>
+        <p:txBody>
+          <a:bodyPr vert="horz" lIns="91440" tIns="45720" rIns="91440" bIns="45720" rtlCol="0" anchor="b"/>
+          <a:lstStyle>
+            <a:lvl1pPr algn="l">
+              <a:defRPr sz="1200"/>
+            </a:lvl1pPr>
+          </a:lstStyle>
+          <a:p>
+            <a:endParaRPr/>
+          </a:p>
+        </p:txBody>
+      </p:sp>
+      <p:sp>
+        <p:nvSpPr>
+          <p:cNvPr id="7" name="Slide Number Placeholder 6"/>
           <p:cNvSpPr>
             <a:spLocks noGrp="1"/>
           </p:cNvSpPr>
@@ -1719,25 +1806,31 @@
             <p:ph type="sldNum" sz="quarter" idx="5"/>
           </p:nvPr>
         </p:nvSpPr>
-        <p:spPr/>
-        <p:txBody>
-          <a:bodyPr/>
-          <a:lstStyle/>
-          <a:p>
-            <a:fld id="{871B2431-D351-4C6E-A3CF-9DFAC0E3E050}" type="slidenum">
-              <a:rPr lang="cs-CZ" smtClean="0"/>
-              <a:t>24</a:t>
-            </a:fld>
-            <a:endParaRPr lang="cs-CZ"/>
+        <p:spPr>
+          <a:xfrm>
+            <a:off x="5180013" y="6502400"/>
+            <a:ext cx="3962400" cy="341313"/>
+          </a:xfrm>
+          <a:prstGeom prst="rect">
+            <a:avLst/>
+          </a:prstGeom>
+        </p:spPr>
+        <p:txBody>
+          <a:bodyPr vert="horz" lIns="91440" tIns="45720" rIns="91440" bIns="45720" rtlCol="0" anchor="b"/>
+          <a:lstStyle>
+            <a:lvl1pPr algn="r">
+              <a:defRPr sz="1200"/>
+            </a:lvl1pPr>
+          </a:lstStyle>
+          <a:p>
+            <a:r>
+              <a:rPr lang="cs-CZ"/>
+              <a:t>‹#›</a:t>
+            </a:r>
           </a:p>
         </p:txBody>
       </p:sp>
     </p:spTree>
-    <p:extLst>
-      <p:ext uri="{BB962C8B-B14F-4D97-AF65-F5344CB8AC3E}">
-        <p14:creationId xmlns:p14="http://schemas.microsoft.com/office/powerpoint/2010/main" val="1306132749"/>
-      </p:ext>
-    </p:extLst>
   </p:cSld>
   <p:clrMapOvr>
     <a:masterClrMapping/>
@@ -1839,8 +1932,8 @@
         </p:nvSpPr>
         <p:spPr>
           <a:xfrm>
-            <a:off x="2290763" y="512763"/>
-            <a:ext cx="4562475" cy="2566987"/>
+            <a:off x="2857500" y="512763"/>
+            <a:ext cx="3429000" cy="2566987"/>
           </a:xfrm>
           <a:prstGeom prst="rect">
             <a:avLst/>
@@ -1885,19 +1978,7 @@
           <a:p>
             <a:r>
               <a:rPr lang="en-US"/>
-              <a:t>Exemple: Sélectionner des candidatures sur base de CV</a:t>
-            </a:r>
-          </a:p>
-          <a:p>
-            <a:r>
-              <a:rPr lang="en-US"/>
-              <a:t>Provider : l’entreprise qui développe l’outil et le vend : elle doit s’assurer que le système est correctement testé, documenté et conforme à l’AI Act.</a:t>
-            </a:r>
-          </a:p>
-          <a:p>
-            <a:r>
-              <a:rPr lang="en-US"/>
-              <a:t>Deployer : l’organisation qui utilise cet outil pour ses recrutements : elle doit l’utiliser correctement, former les personnes qui s’en servent, vérifier les résultats, garder une supervision humaine et informer les candidat·es qu'un outil est utilisé</a:t>
+              <a:t>L’exemple est intéressant car il ne s’agit pas seulement de “robots tueurs” totalement autonomes, mais d’un cas plus réaliste : des systèmes d’IA qui aident à identifier des cibles militaires. Cela pose une question centrale d’accountability : si une IA recommande une cible et que des civils sont tués, qui est responsable ? Le concepteur du système, l’armée, le commandant, l’opérateur humain qui valide, ou l’État ? Human Rights Watch souligne en 2025 que l’usage de l’IA dans les décisions de ciblage militaire peut mettre en danger les principes du droit international humanitaire, notamment la distinction entre combattants et civils, et l’obligation de prendre toutes les précautions possibles pour limiter les dommages civils.</a:t>
             </a:r>
           </a:p>
         </p:txBody>
@@ -1968,6 +2049,107 @@
         </p:txBody>
       </p:sp>
     </p:spTree>
+  </p:cSld>
+  <p:clrMapOvr>
+    <a:masterClrMapping/>
+  </p:clrMapOvr>
+</p:notes>
+</file>
+
+<file path=ppt/notesSlides/notesSlide9.xml><?xml version="1.0" encoding="utf-8"?>
+<p:notes xmlns:a="http://schemas.openxmlformats.org/drawingml/2006/main" xmlns:r="http://schemas.openxmlformats.org/officeDocument/2006/relationships" xmlns:p="http://schemas.openxmlformats.org/presentationml/2006/main">
+  <p:cSld>
+    <p:spTree>
+      <p:nvGrpSpPr>
+        <p:cNvPr id="1" name=""/>
+        <p:cNvGrpSpPr/>
+        <p:nvPr/>
+      </p:nvGrpSpPr>
+      <p:grpSpPr>
+        <a:xfrm>
+          <a:off x="0" y="0"/>
+          <a:ext cx="0" cy="0"/>
+          <a:chOff x="0" y="0"/>
+          <a:chExt cx="0" cy="0"/>
+        </a:xfrm>
+      </p:grpSpPr>
+      <p:sp>
+        <p:nvSpPr>
+          <p:cNvPr id="2" name="Espace réservé de l'image des diapositives 1"/>
+          <p:cNvSpPr>
+            <a:spLocks noGrp="1" noRot="1" noChangeAspect="1"/>
+          </p:cNvSpPr>
+          <p:nvPr>
+            <p:ph type="sldImg"/>
+          </p:nvPr>
+        </p:nvSpPr>
+        <p:spPr>
+          <a:xfrm>
+            <a:off x="2290763" y="512763"/>
+            <a:ext cx="4562475" cy="2566987"/>
+          </a:xfrm>
+        </p:spPr>
+      </p:sp>
+      <p:sp>
+        <p:nvSpPr>
+          <p:cNvPr id="3" name="Espace réservé des notes 2"/>
+          <p:cNvSpPr>
+            <a:spLocks noGrp="1"/>
+          </p:cNvSpPr>
+          <p:nvPr>
+            <p:ph type="body" idx="1"/>
+          </p:nvPr>
+        </p:nvSpPr>
+        <p:spPr/>
+        <p:txBody>
+          <a:bodyPr/>
+          <a:lstStyle/>
+          <a:p>
+            <a:r>
+              <a:rPr lang="fr-FR" dirty="0"/>
+              <a:t>Des principes éthiques aux obligations juridiques : l’AI </a:t>
+            </a:r>
+            <a:r>
+              <a:rPr lang="fr-FR" dirty="0" err="1"/>
+              <a:t>Act</a:t>
+            </a:r>
+            <a:r>
+              <a:rPr lang="fr-FR" dirty="0"/>
+              <a:t> traduit certains risques en règles concrètes. </a:t>
+            </a:r>
+            <a:endParaRPr lang="fr-BE" dirty="0"/>
+          </a:p>
+        </p:txBody>
+      </p:sp>
+      <p:sp>
+        <p:nvSpPr>
+          <p:cNvPr id="4" name="Espace réservé du numéro de diapositive 3"/>
+          <p:cNvSpPr>
+            <a:spLocks noGrp="1"/>
+          </p:cNvSpPr>
+          <p:nvPr>
+            <p:ph type="sldNum" sz="quarter" idx="5"/>
+          </p:nvPr>
+        </p:nvSpPr>
+        <p:spPr/>
+        <p:txBody>
+          <a:bodyPr/>
+          <a:lstStyle/>
+          <a:p>
+            <a:fld id="{871B2431-D351-4C6E-A3CF-9DFAC0E3E050}" type="slidenum">
+              <a:rPr lang="cs-CZ" smtClean="0"/>
+              <a:t>24</a:t>
+            </a:fld>
+            <a:endParaRPr lang="cs-CZ"/>
+          </a:p>
+        </p:txBody>
+      </p:sp>
+    </p:spTree>
+    <p:extLst>
+      <p:ext uri="{BB962C8B-B14F-4D97-AF65-F5344CB8AC3E}">
+        <p14:creationId xmlns:p14="http://schemas.microsoft.com/office/powerpoint/2010/main" val="1306132749"/>
+      </p:ext>
+    </p:extLst>
   </p:cSld>
   <p:clrMapOvr>
     <a:masterClrMapping/>
@@ -2155,7 +2337,7 @@
             <a:fld id="{1D8BD707-D9CF-40AE-B4C6-C98DA3205C09}" type="datetimeFigureOut">
               <a:rPr lang="en-US" smtClean="0"/>
               <a:pPr/>
-              <a:t>6/12/2026</a:t>
+              <a:t>6/15/26</a:t>
             </a:fld>
             <a:endParaRPr lang="en-US"/>
           </a:p>
@@ -2320,7 +2502,7 @@
             <a:fld id="{1D8BD707-D9CF-40AE-B4C6-C98DA3205C09}" type="datetimeFigureOut">
               <a:rPr lang="en-US" smtClean="0"/>
               <a:pPr/>
-              <a:t>6/12/2026</a:t>
+              <a:t>6/15/26</a:t>
             </a:fld>
             <a:endParaRPr lang="en-US"/>
           </a:p>
@@ -2495,7 +2677,7 @@
             <a:fld id="{1D8BD707-D9CF-40AE-B4C6-C98DA3205C09}" type="datetimeFigureOut">
               <a:rPr lang="en-US" smtClean="0"/>
               <a:pPr/>
-              <a:t>6/12/2026</a:t>
+              <a:t>6/15/26</a:t>
             </a:fld>
             <a:endParaRPr lang="en-US"/>
           </a:p>
@@ -2660,7 +2842,7 @@
             <a:fld id="{1D8BD707-D9CF-40AE-B4C6-C98DA3205C09}" type="datetimeFigureOut">
               <a:rPr lang="en-US" smtClean="0"/>
               <a:pPr/>
-              <a:t>6/12/2026</a:t>
+              <a:t>6/15/26</a:t>
             </a:fld>
             <a:endParaRPr lang="en-US"/>
           </a:p>
@@ -2902,7 +3084,7 @@
             <a:fld id="{1D8BD707-D9CF-40AE-B4C6-C98DA3205C09}" type="datetimeFigureOut">
               <a:rPr lang="en-US" smtClean="0"/>
               <a:pPr/>
-              <a:t>6/12/2026</a:t>
+              <a:t>6/15/26</a:t>
             </a:fld>
             <a:endParaRPr lang="en-US"/>
           </a:p>
@@ -3184,7 +3366,7 @@
             <a:fld id="{1D8BD707-D9CF-40AE-B4C6-C98DA3205C09}" type="datetimeFigureOut">
               <a:rPr lang="en-US" smtClean="0"/>
               <a:pPr/>
-              <a:t>6/12/2026</a:t>
+              <a:t>6/15/26</a:t>
             </a:fld>
             <a:endParaRPr lang="en-US"/>
           </a:p>
@@ -3600,7 +3782,7 @@
             <a:fld id="{1D8BD707-D9CF-40AE-B4C6-C98DA3205C09}" type="datetimeFigureOut">
               <a:rPr lang="en-US" smtClean="0"/>
               <a:pPr/>
-              <a:t>6/12/2026</a:t>
+              <a:t>6/15/26</a:t>
             </a:fld>
             <a:endParaRPr lang="en-US"/>
           </a:p>
@@ -3714,7 +3896,7 @@
             <a:fld id="{1D8BD707-D9CF-40AE-B4C6-C98DA3205C09}" type="datetimeFigureOut">
               <a:rPr lang="en-US" smtClean="0"/>
               <a:pPr/>
-              <a:t>6/12/2026</a:t>
+              <a:t>6/15/26</a:t>
             </a:fld>
             <a:endParaRPr lang="en-US"/>
           </a:p>
@@ -3806,7 +3988,7 @@
             <a:fld id="{1D8BD707-D9CF-40AE-B4C6-C98DA3205C09}" type="datetimeFigureOut">
               <a:rPr lang="en-US" smtClean="0"/>
               <a:pPr/>
-              <a:t>6/12/2026</a:t>
+              <a:t>6/15/26</a:t>
             </a:fld>
             <a:endParaRPr lang="en-US"/>
           </a:p>
@@ -4078,7 +4260,7 @@
             <a:fld id="{1D8BD707-D9CF-40AE-B4C6-C98DA3205C09}" type="datetimeFigureOut">
               <a:rPr lang="en-US" smtClean="0"/>
               <a:pPr/>
-              <a:t>6/12/2026</a:t>
+              <a:t>6/15/26</a:t>
             </a:fld>
             <a:endParaRPr lang="en-US"/>
           </a:p>
@@ -4327,7 +4509,7 @@
             <a:fld id="{1D8BD707-D9CF-40AE-B4C6-C98DA3205C09}" type="datetimeFigureOut">
               <a:rPr lang="en-US" smtClean="0"/>
               <a:pPr/>
-              <a:t>6/12/2026</a:t>
+              <a:t>6/15/26</a:t>
             </a:fld>
             <a:endParaRPr lang="en-US"/>
           </a:p>
@@ -4535,7 +4717,7 @@
             <a:fld id="{1D8BD707-D9CF-40AE-B4C6-C98DA3205C09}" type="datetimeFigureOut">
               <a:rPr lang="en-US" smtClean="0"/>
               <a:pPr/>
-              <a:t>6/12/2026</a:t>
+              <a:t>6/15/26</a:t>
             </a:fld>
             <a:endParaRPr lang="en-US"/>
           </a:p>
@@ -6566,7 +6748,7 @@
               </a:spcBef>
             </a:pPr>
             <a:r>
-              <a:rPr lang="en-US" sz="3200">
+              <a:rPr lang="en-US" sz="3200" dirty="0">
                 <a:solidFill>
                   <a:srgbClr val="1E325C"/>
                 </a:solidFill>
@@ -6575,7 +6757,199 @@
                 <a:cs typeface="Open Sans"/>
                 <a:sym typeface="Open Sans"/>
               </a:rPr>
-              <a:t>2024 : Clearview AI est sanctionnée pour avoir constitué illégalement une base de données biométriques destinée à la reconnaissance faciale.</a:t>
+              <a:t>2024 : Clearview AI est </a:t>
+            </a:r>
+            <a:r>
+              <a:rPr lang="en-US" sz="3200" dirty="0" err="1">
+                <a:solidFill>
+                  <a:srgbClr val="1E325C"/>
+                </a:solidFill>
+                <a:latin typeface="Open Sans"/>
+                <a:ea typeface="Open Sans"/>
+                <a:cs typeface="Open Sans"/>
+                <a:sym typeface="Open Sans"/>
+              </a:rPr>
+              <a:t>sanctionnée</a:t>
+            </a:r>
+            <a:r>
+              <a:rPr lang="en-US" sz="3200" dirty="0">
+                <a:solidFill>
+                  <a:srgbClr val="1E325C"/>
+                </a:solidFill>
+                <a:latin typeface="Open Sans"/>
+                <a:ea typeface="Open Sans"/>
+                <a:cs typeface="Open Sans"/>
+                <a:sym typeface="Open Sans"/>
+              </a:rPr>
+              <a:t> pour </a:t>
+            </a:r>
+            <a:r>
+              <a:rPr lang="en-US" sz="3200" dirty="0" err="1">
+                <a:solidFill>
+                  <a:srgbClr val="1E325C"/>
+                </a:solidFill>
+                <a:latin typeface="Open Sans"/>
+                <a:ea typeface="Open Sans"/>
+                <a:cs typeface="Open Sans"/>
+                <a:sym typeface="Open Sans"/>
+              </a:rPr>
+              <a:t>avoir</a:t>
+            </a:r>
+            <a:r>
+              <a:rPr lang="en-US" sz="3200" dirty="0">
+                <a:solidFill>
+                  <a:srgbClr val="1E325C"/>
+                </a:solidFill>
+                <a:latin typeface="Open Sans"/>
+                <a:ea typeface="Open Sans"/>
+                <a:cs typeface="Open Sans"/>
+                <a:sym typeface="Open Sans"/>
+              </a:rPr>
+              <a:t> </a:t>
+            </a:r>
+            <a:r>
+              <a:rPr lang="en-US" sz="3200" dirty="0" err="1">
+                <a:solidFill>
+                  <a:srgbClr val="1E325C"/>
+                </a:solidFill>
+                <a:latin typeface="Open Sans"/>
+                <a:ea typeface="Open Sans"/>
+                <a:cs typeface="Open Sans"/>
+                <a:sym typeface="Open Sans"/>
+              </a:rPr>
+              <a:t>constitué</a:t>
+            </a:r>
+            <a:r>
+              <a:rPr lang="en-US" sz="3200" dirty="0">
+                <a:solidFill>
+                  <a:srgbClr val="1E325C"/>
+                </a:solidFill>
+                <a:latin typeface="Open Sans"/>
+                <a:ea typeface="Open Sans"/>
+                <a:cs typeface="Open Sans"/>
+                <a:sym typeface="Open Sans"/>
+              </a:rPr>
+              <a:t> </a:t>
+            </a:r>
+            <a:r>
+              <a:rPr lang="en-US" sz="3200" dirty="0" err="1">
+                <a:solidFill>
+                  <a:srgbClr val="1E325C"/>
+                </a:solidFill>
+                <a:latin typeface="Open Sans"/>
+                <a:ea typeface="Open Sans"/>
+                <a:cs typeface="Open Sans"/>
+                <a:sym typeface="Open Sans"/>
+              </a:rPr>
+              <a:t>illégalement</a:t>
+            </a:r>
+            <a:r>
+              <a:rPr lang="en-US" sz="3200" dirty="0">
+                <a:solidFill>
+                  <a:srgbClr val="1E325C"/>
+                </a:solidFill>
+                <a:latin typeface="Open Sans"/>
+                <a:ea typeface="Open Sans"/>
+                <a:cs typeface="Open Sans"/>
+                <a:sym typeface="Open Sans"/>
+              </a:rPr>
+              <a:t> </a:t>
+            </a:r>
+            <a:r>
+              <a:rPr lang="en-US" sz="3200" dirty="0" err="1">
+                <a:solidFill>
+                  <a:srgbClr val="1E325C"/>
+                </a:solidFill>
+                <a:latin typeface="Open Sans"/>
+                <a:ea typeface="Open Sans"/>
+                <a:cs typeface="Open Sans"/>
+                <a:sym typeface="Open Sans"/>
+              </a:rPr>
+              <a:t>une</a:t>
+            </a:r>
+            <a:r>
+              <a:rPr lang="en-US" sz="3200" dirty="0">
+                <a:solidFill>
+                  <a:srgbClr val="1E325C"/>
+                </a:solidFill>
+                <a:latin typeface="Open Sans"/>
+                <a:ea typeface="Open Sans"/>
+                <a:cs typeface="Open Sans"/>
+                <a:sym typeface="Open Sans"/>
+              </a:rPr>
+              <a:t> base de données </a:t>
+            </a:r>
+            <a:r>
+              <a:rPr lang="en-US" sz="3200" dirty="0" err="1">
+                <a:solidFill>
+                  <a:srgbClr val="1E325C"/>
+                </a:solidFill>
+                <a:latin typeface="Open Sans"/>
+                <a:ea typeface="Open Sans"/>
+                <a:cs typeface="Open Sans"/>
+                <a:sym typeface="Open Sans"/>
+              </a:rPr>
+              <a:t>biométriques</a:t>
+            </a:r>
+            <a:r>
+              <a:rPr lang="en-US" sz="3200" dirty="0">
+                <a:solidFill>
+                  <a:srgbClr val="1E325C"/>
+                </a:solidFill>
+                <a:latin typeface="Open Sans"/>
+                <a:ea typeface="Open Sans"/>
+                <a:cs typeface="Open Sans"/>
+                <a:sym typeface="Open Sans"/>
+              </a:rPr>
+              <a:t> </a:t>
+            </a:r>
+            <a:r>
+              <a:rPr lang="en-US" sz="3200" dirty="0" err="1">
+                <a:solidFill>
+                  <a:srgbClr val="1E325C"/>
+                </a:solidFill>
+                <a:latin typeface="Open Sans"/>
+                <a:ea typeface="Open Sans"/>
+                <a:cs typeface="Open Sans"/>
+                <a:sym typeface="Open Sans"/>
+              </a:rPr>
+              <a:t>destinée</a:t>
+            </a:r>
+            <a:r>
+              <a:rPr lang="en-US" sz="3200" dirty="0">
+                <a:solidFill>
+                  <a:srgbClr val="1E325C"/>
+                </a:solidFill>
+                <a:latin typeface="Open Sans"/>
+                <a:ea typeface="Open Sans"/>
+                <a:cs typeface="Open Sans"/>
+                <a:sym typeface="Open Sans"/>
+              </a:rPr>
+              <a:t> à la reconnaissance </a:t>
+            </a:r>
+            <a:r>
+              <a:rPr lang="en-US" sz="3200" dirty="0" err="1">
+                <a:solidFill>
+                  <a:srgbClr val="1E325C"/>
+                </a:solidFill>
+                <a:latin typeface="Open Sans"/>
+                <a:ea typeface="Open Sans"/>
+                <a:cs typeface="Open Sans"/>
+                <a:sym typeface="Open Sans"/>
+              </a:rPr>
+              <a:t>faciale</a:t>
+            </a:r>
+            <a:r>
+              <a:rPr lang="en-US" sz="3200" dirty="0">
+                <a:solidFill>
+                  <a:srgbClr val="1E325C"/>
+                </a:solidFill>
+                <a:latin typeface="Open Sans"/>
+                <a:ea typeface="Open Sans"/>
+                <a:cs typeface="Open Sans"/>
+                <a:sym typeface="Open Sans"/>
+              </a:rPr>
+              <a:t>.</a:t>
             </a:r>
           </a:p>
         </p:txBody>
@@ -21024,14 +21398,14 @@
         <p:spPr>
           <a:xfrm>
             <a:off x="735956" y="659116"/>
-            <a:ext cx="9233407" cy="762054"/>
+            <a:ext cx="16409044" cy="754950"/>
           </a:xfrm>
           <a:prstGeom prst="rect">
             <a:avLst/>
           </a:prstGeom>
         </p:spPr>
         <p:txBody>
-          <a:bodyPr lIns="0" tIns="0" rIns="0" bIns="0" rtlCol="0" anchor="t">
+          <a:bodyPr wrap="square" lIns="0" tIns="0" rIns="0" bIns="0" rtlCol="0" anchor="t">
             <a:spAutoFit/>
           </a:bodyPr>
           <a:lstStyle/>
@@ -21045,7 +21419,7 @@
               </a:spcBef>
             </a:pPr>
             <a:r>
-              <a:rPr lang="en-US" sz="4500">
+              <a:rPr lang="fr-FR" sz="4500" b="1" noProof="1">
                 <a:solidFill>
                   <a:srgbClr val="000000"/>
                 </a:solidFill>
@@ -21054,7 +21428,218 @@
                 <a:cs typeface="Open Sans"/>
                 <a:sym typeface="Open Sans"/>
               </a:rPr>
-              <a:t>RGPD</a:t>
+              <a:t>RGPD : ressources disponibles sur la question</a:t>
+            </a:r>
+          </a:p>
+        </p:txBody>
+      </p:sp>
+      <p:sp>
+        <p:nvSpPr>
+          <p:cNvPr id="7" name="ZoneTexte 6">
+            <a:extLst>
+              <a:ext uri="{FF2B5EF4-FFF2-40B4-BE49-F238E27FC236}">
+                <a16:creationId xmlns:a16="http://schemas.microsoft.com/office/drawing/2014/main" id="{1D95E32E-8269-9DE4-C90A-2B76E89E16F1}"/>
+              </a:ext>
+            </a:extLst>
+          </p:cNvPr>
+          <p:cNvSpPr txBox="1"/>
+          <p:nvPr/>
+        </p:nvSpPr>
+        <p:spPr>
+          <a:xfrm>
+            <a:off x="1398598" y="1790700"/>
+            <a:ext cx="15746402" cy="8279190"/>
+          </a:xfrm>
+          <a:prstGeom prst="rect">
+            <a:avLst/>
+          </a:prstGeom>
+          <a:noFill/>
+        </p:spPr>
+        <p:txBody>
+          <a:bodyPr wrap="square" rtlCol="0">
+            <a:spAutoFit/>
+          </a:bodyPr>
+          <a:lstStyle/>
+          <a:p>
+            <a:r>
+              <a:rPr lang="fr-FR" sz="3800" noProof="1">
+                <a:latin typeface="Open Sans" panose="020B0606030504020204" pitchFamily="34" charset="0"/>
+                <a:ea typeface="Open Sans" panose="020B0606030504020204" pitchFamily="34" charset="0"/>
+                <a:cs typeface="Open Sans" panose="020B0606030504020204" pitchFamily="34" charset="0"/>
+              </a:rPr>
+              <a:t>ANF TDM et IA  +  ANF IA et données personelles (avec spd cnrs)</a:t>
+            </a:r>
+          </a:p>
+          <a:p>
+            <a:pPr marL="1028700" lvl="1" indent="-571500">
+              <a:buFont typeface="Arial" panose="020B0604020202020204" pitchFamily="34" charset="0"/>
+              <a:buChar char="•"/>
+            </a:pPr>
+            <a:r>
+              <a:rPr lang="fr-FR" sz="3800" noProof="1">
+                <a:latin typeface="Open Sans" panose="020B0606030504020204" pitchFamily="34" charset="0"/>
+                <a:ea typeface="Open Sans" panose="020B0606030504020204" pitchFamily="34" charset="0"/>
+                <a:cs typeface="Open Sans" panose="020B0606030504020204" pitchFamily="34" charset="0"/>
+              </a:rPr>
+              <a:t>Notamment les diapos intervention CNIL</a:t>
+            </a:r>
+          </a:p>
+          <a:p>
+            <a:pPr marL="1028700" lvl="1" indent="-571500">
+              <a:buFont typeface="Arial" panose="020B0604020202020204" pitchFamily="34" charset="0"/>
+              <a:buChar char="•"/>
+            </a:pPr>
+            <a:r>
+              <a:rPr lang="fr-FR" sz="3800" noProof="1">
+                <a:latin typeface="Open Sans" panose="020B0606030504020204" pitchFamily="34" charset="0"/>
+                <a:ea typeface="Open Sans" panose="020B0606030504020204" pitchFamily="34" charset="0"/>
+                <a:cs typeface="Open Sans" panose="020B0606030504020204" pitchFamily="34" charset="0"/>
+              </a:rPr>
+              <a:t>Présentation Lionel Maurel (voir dessous)</a:t>
+            </a:r>
+          </a:p>
+          <a:p>
+            <a:endParaRPr lang="fr-FR" sz="3800" noProof="1">
+              <a:latin typeface="Open Sans" panose="020B0606030504020204" pitchFamily="34" charset="0"/>
+              <a:ea typeface="Open Sans" panose="020B0606030504020204" pitchFamily="34" charset="0"/>
+              <a:cs typeface="Open Sans" panose="020B0606030504020204" pitchFamily="34" charset="0"/>
+            </a:endParaRPr>
+          </a:p>
+          <a:p>
+            <a:r>
+              <a:rPr lang="fr-FR" sz="3800" noProof="1">
+                <a:latin typeface="Open Sans" panose="020B0606030504020204" pitchFamily="34" charset="0"/>
+                <a:ea typeface="Open Sans" panose="020B0606030504020204" pitchFamily="34" charset="0"/>
+                <a:cs typeface="Open Sans" panose="020B0606030504020204" pitchFamily="34" charset="0"/>
+              </a:rPr>
+              <a:t>Fiches CNIL</a:t>
+            </a:r>
+          </a:p>
+          <a:p>
+            <a:pPr marL="1028700" lvl="1" indent="-571500">
+              <a:buFont typeface="Arial" panose="020B0604020202020204" pitchFamily="34" charset="0"/>
+              <a:buChar char="•"/>
+            </a:pPr>
+            <a:r>
+              <a:rPr lang="fr-FR" sz="3800" noProof="1">
+                <a:latin typeface="Open Sans" panose="020B0606030504020204" pitchFamily="34" charset="0"/>
+                <a:ea typeface="Open Sans" panose="020B0606030504020204" pitchFamily="34" charset="0"/>
+                <a:cs typeface="Open Sans" panose="020B0606030504020204" pitchFamily="34" charset="0"/>
+                <a:hlinkClick r:id="rId3"/>
+              </a:rPr>
+              <a:t>Fiches pratiques IA</a:t>
+            </a:r>
+            <a:r>
+              <a:rPr lang="fr-FR" sz="3800" noProof="1">
+                <a:latin typeface="Open Sans" panose="020B0606030504020204" pitchFamily="34" charset="0"/>
+                <a:ea typeface="Open Sans" panose="020B0606030504020204" pitchFamily="34" charset="0"/>
+                <a:cs typeface="Open Sans" panose="020B0606030504020204" pitchFamily="34" charset="0"/>
+              </a:rPr>
+              <a:t> ; </a:t>
+            </a:r>
+            <a:r>
+              <a:rPr lang="fr-FR" sz="3800" noProof="1">
+                <a:latin typeface="Open Sans" panose="020B0606030504020204" pitchFamily="34" charset="0"/>
+                <a:ea typeface="Open Sans" panose="020B0606030504020204" pitchFamily="34" charset="0"/>
+                <a:cs typeface="Open Sans" panose="020B0606030504020204" pitchFamily="34" charset="0"/>
+                <a:hlinkClick r:id="rId4"/>
+              </a:rPr>
+              <a:t>IA et GPD</a:t>
+            </a:r>
+            <a:endParaRPr lang="fr-FR" sz="3800" noProof="1">
+              <a:latin typeface="Open Sans" panose="020B0606030504020204" pitchFamily="34" charset="0"/>
+              <a:ea typeface="Open Sans" panose="020B0606030504020204" pitchFamily="34" charset="0"/>
+              <a:cs typeface="Open Sans" panose="020B0606030504020204" pitchFamily="34" charset="0"/>
+            </a:endParaRPr>
+          </a:p>
+          <a:p>
+            <a:endParaRPr lang="fr-FR" sz="3800" noProof="1">
+              <a:latin typeface="Open Sans" panose="020B0606030504020204" pitchFamily="34" charset="0"/>
+              <a:ea typeface="Open Sans" panose="020B0606030504020204" pitchFamily="34" charset="0"/>
+              <a:cs typeface="Open Sans" panose="020B0606030504020204" pitchFamily="34" charset="0"/>
+            </a:endParaRPr>
+          </a:p>
+          <a:p>
+            <a:r>
+              <a:rPr lang="fr-FR" sz="3800" noProof="1">
+                <a:latin typeface="Open Sans" panose="020B0606030504020204" pitchFamily="34" charset="0"/>
+                <a:ea typeface="Open Sans" panose="020B0606030504020204" pitchFamily="34" charset="0"/>
+                <a:cs typeface="Open Sans" panose="020B0606030504020204" pitchFamily="34" charset="0"/>
+              </a:rPr>
+              <a:t>Collecte données et exemption recherche</a:t>
+            </a:r>
+          </a:p>
+          <a:p>
+            <a:pPr marL="1028700" lvl="1" indent="-571500">
+              <a:buFont typeface="Arial" panose="020B0604020202020204" pitchFamily="34" charset="0"/>
+              <a:buChar char="•"/>
+            </a:pPr>
+            <a:r>
+              <a:rPr lang="fr-FR" sz="3800" noProof="1">
+                <a:latin typeface="Open Sans" panose="020B0606030504020204" pitchFamily="34" charset="0"/>
+                <a:ea typeface="Open Sans" panose="020B0606030504020204" pitchFamily="34" charset="0"/>
+                <a:cs typeface="Open Sans" panose="020B0606030504020204" pitchFamily="34" charset="0"/>
+              </a:rPr>
+              <a:t>Article 40.8 du Digital Service Act (DSA)</a:t>
+            </a:r>
+          </a:p>
+          <a:p>
+            <a:pPr marL="1028700" lvl="1" indent="-571500">
+              <a:buFont typeface="Arial" panose="020B0604020202020204" pitchFamily="34" charset="0"/>
+              <a:buChar char="•"/>
+            </a:pPr>
+            <a:r>
+              <a:rPr lang="fr-FR" sz="3800" noProof="1">
+                <a:latin typeface="Open Sans" panose="020B0606030504020204" pitchFamily="34" charset="0"/>
+                <a:ea typeface="Open Sans" panose="020B0606030504020204" pitchFamily="34" charset="0"/>
+                <a:cs typeface="Open Sans" panose="020B0606030504020204" pitchFamily="34" charset="0"/>
+              </a:rPr>
+              <a:t>Exemption CPI L122-5 / L122-5-3</a:t>
+            </a:r>
+          </a:p>
+          <a:p>
+            <a:pPr marL="1485900" lvl="2" indent="-571500">
+              <a:buFont typeface="Arial" panose="020B0604020202020204" pitchFamily="34" charset="0"/>
+              <a:buChar char="•"/>
+            </a:pPr>
+            <a:r>
+              <a:rPr lang="fr-FR" sz="3800" noProof="1">
+                <a:latin typeface="Open Sans" panose="020B0606030504020204" pitchFamily="34" charset="0"/>
+                <a:ea typeface="Open Sans" panose="020B0606030504020204" pitchFamily="34" charset="0"/>
+                <a:cs typeface="Open Sans" panose="020B0606030504020204" pitchFamily="34" charset="0"/>
+              </a:rPr>
+              <a:t>Diapo SPD : Focus - Réutilisation de données accessibles sur les réseaux sociaux </a:t>
+            </a:r>
+          </a:p>
+          <a:p>
+            <a:pPr marL="1485900" lvl="2" indent="-571500">
+              <a:buFont typeface="Arial" panose="020B0604020202020204" pitchFamily="34" charset="0"/>
+              <a:buChar char="•"/>
+            </a:pPr>
+            <a:r>
+              <a:rPr lang="fr-FR" sz="3800" noProof="1">
+                <a:latin typeface="Open Sans" panose="020B0606030504020204" pitchFamily="34" charset="0"/>
+                <a:ea typeface="Open Sans" panose="020B0606030504020204" pitchFamily="34" charset="0"/>
+                <a:cs typeface="Open Sans" panose="020B0606030504020204" pitchFamily="34" charset="0"/>
+              </a:rPr>
+              <a:t>Présentation Lionel Maurel </a:t>
+            </a:r>
+            <a:r>
+              <a:rPr lang="fr-FR" sz="3800" noProof="1">
+                <a:latin typeface="Open Sans" panose="020B0606030504020204" pitchFamily="34" charset="0"/>
+                <a:ea typeface="Open Sans" panose="020B0606030504020204" pitchFamily="34" charset="0"/>
+                <a:cs typeface="Open Sans" panose="020B0606030504020204" pitchFamily="34" charset="0"/>
+                <a:hlinkClick r:id="rId5"/>
+              </a:rPr>
+              <a:t>Fouille de textes et IA : enjeux juridiques et réglementaires</a:t>
+            </a:r>
+            <a:r>
+              <a:rPr lang="fr-FR" sz="3800" noProof="1">
+                <a:latin typeface="Open Sans" panose="020B0606030504020204" pitchFamily="34" charset="0"/>
+                <a:ea typeface="Open Sans" panose="020B0606030504020204" pitchFamily="34" charset="0"/>
+                <a:cs typeface="Open Sans" panose="020B0606030504020204" pitchFamily="34" charset="0"/>
+              </a:rPr>
+              <a:t>, ANF TDM et IA 2025</a:t>
             </a:r>
           </a:p>
         </p:txBody>
@@ -21093,14 +21678,14 @@
         <p:spPr>
           <a:xfrm>
             <a:off x="735956" y="659116"/>
-            <a:ext cx="9233407" cy="762054"/>
+            <a:ext cx="16409044" cy="754887"/>
           </a:xfrm>
           <a:prstGeom prst="rect">
             <a:avLst/>
           </a:prstGeom>
         </p:spPr>
         <p:txBody>
-          <a:bodyPr lIns="0" tIns="0" rIns="0" bIns="0" rtlCol="0" anchor="t">
+          <a:bodyPr wrap="square" lIns="0" tIns="0" rIns="0" bIns="0" rtlCol="0" anchor="t">
             <a:spAutoFit/>
           </a:bodyPr>
           <a:lstStyle/>
@@ -21114,7 +21699,7 @@
               </a:spcBef>
             </a:pPr>
             <a:r>
-              <a:rPr lang="en-US" sz="4500">
+              <a:rPr lang="fr-FR" sz="4500" b="1" noProof="1">
                 <a:solidFill>
                   <a:srgbClr val="000000"/>
                 </a:solidFill>
@@ -21123,7 +21708,111 @@
                 <a:cs typeface="Open Sans"/>
                 <a:sym typeface="Open Sans"/>
               </a:rPr>
-              <a:t>RGPD</a:t>
+              <a:t>RGPD : traitements (et sous-traitants)</a:t>
+            </a:r>
+          </a:p>
+        </p:txBody>
+      </p:sp>
+      <p:sp>
+        <p:nvSpPr>
+          <p:cNvPr id="4" name="ZoneTexte 3">
+            <a:extLst>
+              <a:ext uri="{FF2B5EF4-FFF2-40B4-BE49-F238E27FC236}">
+                <a16:creationId xmlns:a16="http://schemas.microsoft.com/office/drawing/2014/main" id="{276335BE-CC8D-E143-60A7-84BC4D71B7A0}"/>
+              </a:ext>
+            </a:extLst>
+          </p:cNvPr>
+          <p:cNvSpPr txBox="1"/>
+          <p:nvPr/>
+        </p:nvSpPr>
+        <p:spPr>
+          <a:xfrm>
+            <a:off x="1398598" y="2253672"/>
+            <a:ext cx="15746402" cy="4185761"/>
+          </a:xfrm>
+          <a:prstGeom prst="rect">
+            <a:avLst/>
+          </a:prstGeom>
+          <a:noFill/>
+        </p:spPr>
+        <p:txBody>
+          <a:bodyPr wrap="square" rtlCol="0">
+            <a:spAutoFit/>
+          </a:bodyPr>
+          <a:lstStyle/>
+          <a:p>
+            <a:r>
+              <a:rPr lang="fr-FR" sz="3800" dirty="0">
+                <a:latin typeface="Open Sans" panose="020B0606030504020204" pitchFamily="34" charset="0"/>
+                <a:ea typeface="Open Sans" panose="020B0606030504020204" pitchFamily="34" charset="0"/>
+                <a:cs typeface="Open Sans" panose="020B0606030504020204" pitchFamily="34" charset="0"/>
+              </a:rPr>
+              <a:t>Recommandations si usage d’IA générative (notamment LLM)</a:t>
+            </a:r>
+          </a:p>
+          <a:p>
+            <a:endParaRPr lang="fr-FR" sz="3800" dirty="0">
+              <a:latin typeface="Open Sans" panose="020B0606030504020204" pitchFamily="34" charset="0"/>
+              <a:ea typeface="Open Sans" panose="020B0606030504020204" pitchFamily="34" charset="0"/>
+              <a:cs typeface="Open Sans" panose="020B0606030504020204" pitchFamily="34" charset="0"/>
+            </a:endParaRPr>
+          </a:p>
+          <a:p>
+            <a:pPr marL="571500" indent="-571500">
+              <a:buFont typeface="Arial" panose="020B0604020202020204" pitchFamily="34" charset="0"/>
+              <a:buChar char="•"/>
+            </a:pPr>
+            <a:r>
+              <a:rPr lang="fr-FR" sz="3800" dirty="0">
+                <a:latin typeface="Open Sans" panose="020B0606030504020204" pitchFamily="34" charset="0"/>
+                <a:ea typeface="Open Sans" panose="020B0606030504020204" pitchFamily="34" charset="0"/>
+                <a:cs typeface="Open Sans" panose="020B0606030504020204" pitchFamily="34" charset="0"/>
+              </a:rPr>
+              <a:t>Utiliser des plateformes publiques sécurisées</a:t>
+            </a:r>
+          </a:p>
+          <a:p>
+            <a:pPr marL="571500" indent="-571500">
+              <a:buFont typeface="Arial" panose="020B0604020202020204" pitchFamily="34" charset="0"/>
+              <a:buChar char="•"/>
+            </a:pPr>
+            <a:r>
+              <a:rPr lang="fr-FR" sz="3800" dirty="0">
+                <a:latin typeface="Open Sans" panose="020B0606030504020204" pitchFamily="34" charset="0"/>
+                <a:ea typeface="Open Sans" panose="020B0606030504020204" pitchFamily="34" charset="0"/>
+                <a:cs typeface="Open Sans" panose="020B0606030504020204" pitchFamily="34" charset="0"/>
+              </a:rPr>
+              <a:t>Faire tourner un modèle en local</a:t>
+            </a:r>
+          </a:p>
+          <a:p>
+            <a:pPr marL="571500" indent="-571500">
+              <a:buFont typeface="Arial" panose="020B0604020202020204" pitchFamily="34" charset="0"/>
+              <a:buChar char="•"/>
+            </a:pPr>
+            <a:r>
+              <a:rPr lang="fr-FR" sz="3800" dirty="0">
+                <a:latin typeface="Open Sans" panose="020B0606030504020204" pitchFamily="34" charset="0"/>
+                <a:ea typeface="Open Sans" panose="020B0606030504020204" pitchFamily="34" charset="0"/>
+                <a:cs typeface="Open Sans" panose="020B0606030504020204" pitchFamily="34" charset="0"/>
+              </a:rPr>
+              <a:t>Ne pas envoyer de données personnelles sensibles à des solutions commerciales (sauf cas très particuliers avec déclaration comme sous traitant dans son projet RGPD – good </a:t>
+            </a:r>
+            <a:r>
+              <a:rPr lang="fr-FR" sz="3800" dirty="0" err="1">
+                <a:latin typeface="Open Sans" panose="020B0606030504020204" pitchFamily="34" charset="0"/>
+                <a:ea typeface="Open Sans" panose="020B0606030504020204" pitchFamily="34" charset="0"/>
+                <a:cs typeface="Open Sans" panose="020B0606030504020204" pitchFamily="34" charset="0"/>
+              </a:rPr>
+              <a:t>luck</a:t>
+            </a:r>
+            <a:r>
+              <a:rPr lang="fr-FR" sz="3800" dirty="0">
+                <a:latin typeface="Open Sans" panose="020B0606030504020204" pitchFamily="34" charset="0"/>
+                <a:ea typeface="Open Sans" panose="020B0606030504020204" pitchFamily="34" charset="0"/>
+                <a:cs typeface="Open Sans" panose="020B0606030504020204" pitchFamily="34" charset="0"/>
+              </a:rPr>
+              <a:t>)</a:t>
             </a:r>
           </a:p>
         </p:txBody>
@@ -21439,7 +22128,7 @@
               </a:spcBef>
             </a:pPr>
             <a:r>
-              <a:rPr lang="en-US" sz="3800" i="1">
+              <a:rPr lang="en-US" sz="3800" i="1" dirty="0">
                 <a:solidFill>
                   <a:srgbClr val="479DD3"/>
                 </a:solidFill>
@@ -21451,7 +22140,7 @@
               <a:t>Ethics Guidelines for Trustworthy AI</a:t>
             </a:r>
             <a:r>
-              <a:rPr lang="en-US" sz="3800">
+              <a:rPr lang="en-US" sz="3800" dirty="0">
                 <a:solidFill>
                   <a:srgbClr val="000000"/>
                 </a:solidFill>
@@ -21460,7 +22149,151 @@
                 <a:cs typeface="Open Sans"/>
                 <a:sym typeface="Open Sans"/>
               </a:rPr>
-              <a:t> écrit par un groupe d’experts en IA (HLEG) pour la Commission européenne en 2019.</a:t>
+              <a:t> </a:t>
+            </a:r>
+            <a:r>
+              <a:rPr lang="en-US" sz="3800" dirty="0" err="1">
+                <a:solidFill>
+                  <a:srgbClr val="000000"/>
+                </a:solidFill>
+                <a:latin typeface="Open Sans"/>
+                <a:ea typeface="Open Sans"/>
+                <a:cs typeface="Open Sans"/>
+                <a:sym typeface="Open Sans"/>
+              </a:rPr>
+              <a:t>écrit</a:t>
+            </a:r>
+            <a:r>
+              <a:rPr lang="en-US" sz="3800" dirty="0">
+                <a:solidFill>
+                  <a:srgbClr val="000000"/>
+                </a:solidFill>
+                <a:latin typeface="Open Sans"/>
+                <a:ea typeface="Open Sans"/>
+                <a:cs typeface="Open Sans"/>
+                <a:sym typeface="Open Sans"/>
+              </a:rPr>
+              <a:t> par un </a:t>
+            </a:r>
+            <a:r>
+              <a:rPr lang="en-US" sz="3800" dirty="0" err="1">
+                <a:solidFill>
+                  <a:srgbClr val="000000"/>
+                </a:solidFill>
+                <a:latin typeface="Open Sans"/>
+                <a:ea typeface="Open Sans"/>
+                <a:cs typeface="Open Sans"/>
+                <a:sym typeface="Open Sans"/>
+              </a:rPr>
+              <a:t>groupe</a:t>
+            </a:r>
+            <a:r>
+              <a:rPr lang="en-US" sz="3800" dirty="0">
+                <a:solidFill>
+                  <a:srgbClr val="000000"/>
+                </a:solidFill>
+                <a:latin typeface="Open Sans"/>
+                <a:ea typeface="Open Sans"/>
+                <a:cs typeface="Open Sans"/>
+                <a:sym typeface="Open Sans"/>
+              </a:rPr>
+              <a:t> </a:t>
+            </a:r>
+            <a:r>
+              <a:rPr lang="en-US" sz="3800" dirty="0" err="1">
+                <a:solidFill>
+                  <a:srgbClr val="000000"/>
+                </a:solidFill>
+                <a:latin typeface="Open Sans"/>
+                <a:ea typeface="Open Sans"/>
+                <a:cs typeface="Open Sans"/>
+                <a:sym typeface="Open Sans"/>
+              </a:rPr>
+              <a:t>d’experts</a:t>
+            </a:r>
+            <a:r>
+              <a:rPr lang="en-US" sz="3800" dirty="0">
+                <a:solidFill>
+                  <a:srgbClr val="000000"/>
+                </a:solidFill>
+                <a:latin typeface="Open Sans"/>
+                <a:ea typeface="Open Sans"/>
+                <a:cs typeface="Open Sans"/>
+                <a:sym typeface="Open Sans"/>
+              </a:rPr>
+              <a:t> </a:t>
+            </a:r>
+            <a:r>
+              <a:rPr lang="en-US" sz="3800" dirty="0" err="1">
+                <a:solidFill>
+                  <a:srgbClr val="000000"/>
+                </a:solidFill>
+                <a:latin typeface="Open Sans"/>
+                <a:ea typeface="Open Sans"/>
+                <a:cs typeface="Open Sans"/>
+                <a:sym typeface="Open Sans"/>
+              </a:rPr>
+              <a:t>en</a:t>
+            </a:r>
+            <a:r>
+              <a:rPr lang="en-US" sz="3800" dirty="0">
+                <a:solidFill>
+                  <a:srgbClr val="000000"/>
+                </a:solidFill>
+                <a:latin typeface="Open Sans"/>
+                <a:ea typeface="Open Sans"/>
+                <a:cs typeface="Open Sans"/>
+                <a:sym typeface="Open Sans"/>
+              </a:rPr>
+              <a:t> IA (HLEG) pour la Commission </a:t>
+            </a:r>
+            <a:r>
+              <a:rPr lang="en-US" sz="3800" dirty="0" err="1">
+                <a:solidFill>
+                  <a:srgbClr val="000000"/>
+                </a:solidFill>
+                <a:latin typeface="Open Sans"/>
+                <a:ea typeface="Open Sans"/>
+                <a:cs typeface="Open Sans"/>
+                <a:sym typeface="Open Sans"/>
+              </a:rPr>
+              <a:t>européenne</a:t>
+            </a:r>
+            <a:r>
+              <a:rPr lang="en-US" sz="3800" dirty="0">
+                <a:solidFill>
+                  <a:srgbClr val="000000"/>
+                </a:solidFill>
+                <a:latin typeface="Open Sans"/>
+                <a:ea typeface="Open Sans"/>
+                <a:cs typeface="Open Sans"/>
+                <a:sym typeface="Open Sans"/>
+              </a:rPr>
+              <a:t> </a:t>
+            </a:r>
+            <a:r>
+              <a:rPr lang="en-US" sz="3800" dirty="0" err="1">
+                <a:solidFill>
+                  <a:srgbClr val="000000"/>
+                </a:solidFill>
+                <a:latin typeface="Open Sans"/>
+                <a:ea typeface="Open Sans"/>
+                <a:cs typeface="Open Sans"/>
+                <a:sym typeface="Open Sans"/>
+              </a:rPr>
+              <a:t>en</a:t>
+            </a:r>
+            <a:r>
+              <a:rPr lang="en-US" sz="3800" dirty="0">
+                <a:solidFill>
+                  <a:srgbClr val="000000"/>
+                </a:solidFill>
+                <a:latin typeface="Open Sans"/>
+                <a:ea typeface="Open Sans"/>
+                <a:cs typeface="Open Sans"/>
+                <a:sym typeface="Open Sans"/>
+              </a:rPr>
+              <a:t> 2019.</a:t>
             </a:r>
           </a:p>
         </p:txBody>
@@ -21563,7 +22396,7 @@
               </a:spcBef>
             </a:pPr>
             <a:r>
-              <a:rPr lang="en-US" sz="3800" b="1">
+              <a:rPr lang="en-US" sz="3800" b="1" dirty="0">
                 <a:solidFill>
                   <a:srgbClr val="1E325C"/>
                 </a:solidFill>
@@ -21786,7 +22619,7 @@
               </a:spcBef>
             </a:pPr>
             <a:r>
-              <a:rPr lang="en-US" sz="3800" b="1">
+              <a:rPr lang="en-US" sz="3800" b="1" dirty="0">
                 <a:solidFill>
                   <a:srgbClr val="1E325C"/>
                 </a:solidFill>
@@ -22122,7 +22955,7 @@
               </a:spcBef>
             </a:pPr>
             <a:r>
-              <a:rPr lang="en-US" sz="4500">
+              <a:rPr lang="en-US" sz="4500" dirty="0">
                 <a:solidFill>
                   <a:srgbClr val="000000"/>
                 </a:solidFill>

</xml_diff>